<commit_message>
feat(deck): expand Slide 6 into 6 individual numbered cards (01 to 06) for modern papers (all >= 2023)
</commit_message>
<xml_diff>
--- a/SIH26177_v8.pptx
+++ b/SIH26177_v8.pptx
@@ -38214,14 +38214,14 @@
       </p:grpSp>
       <p:sp>
         <p:nvSpPr>
-          <p:cNvPr name="Freeform 42" id="42"/>
+          <p:cNvPr name="ResearchCard_BG_01" id="401"/>
           <p:cNvSpPr/>
           <p:nvPr/>
         </p:nvSpPr>
         <p:spPr>
           <a:xfrm flipH="false" flipV="false" rot="0">
             <a:off x="810454" y="2511238"/>
-            <a:ext cx="9283303" cy="1561195"/>
+            <a:ext cx="9283303" cy="1049621"/>
           </a:xfrm>
           <a:custGeom>
             <a:avLst/>
@@ -38230,7 +38230,7 @@
             <a:cxnLst/>
             <a:rect r="r" b="b" t="t" l="l"/>
             <a:pathLst>
-              <a:path h="1561195" w="9283303">
+              <a:path h="1049621" w="9283303">
                 <a:moveTo>
                   <a:pt x="0" y="0"/>
                 </a:moveTo>
@@ -38238,10 +38238,10 @@
                   <a:pt x="9283303" y="0"/>
                 </a:lnTo>
                 <a:lnTo>
-                  <a:pt x="9283303" y="1561195"/>
+                  <a:pt x="9283303" y="1049621"/>
                 </a:lnTo>
                 <a:lnTo>
-                  <a:pt x="0" y="1561195"/>
+                  <a:pt x="0" y="1049621"/>
                 </a:lnTo>
                 <a:lnTo>
                   <a:pt x="0" y="0"/>
@@ -38266,13 +38266,13 @@
       </p:sp>
       <p:grpSp>
         <p:nvGrpSpPr>
-          <p:cNvPr name="Group 43" id="43"/>
+          <p:cNvPr name="BadgeShadow_01" id="402"/>
           <p:cNvGrpSpPr/>
           <p:nvPr/>
         </p:nvGrpSpPr>
         <p:grpSpPr>
           <a:xfrm rot="0">
-            <a:off x="1124712" y="2660904"/>
+            <a:off x="1124712" y="2701262"/>
             <a:ext cx="822960" cy="411480"/>
             <a:chOff x="0" y="0"/>
             <a:chExt cx="1097280" cy="548640"/>
@@ -38280,7 +38280,7 @@
         </p:grpSpPr>
         <p:sp>
           <p:nvSpPr>
-            <p:cNvPr name="Freeform 44" id="44"/>
+            <p:cNvPr name="Freeform 44" id="403"/>
             <p:cNvSpPr/>
             <p:nvPr/>
           </p:nvSpPr>
@@ -38326,13 +38326,13 @@
       </p:grpSp>
       <p:grpSp>
         <p:nvGrpSpPr>
-          <p:cNvPr name="Group 45" id="45"/>
+          <p:cNvPr name="BadgeGroup_01" id="404"/>
           <p:cNvGrpSpPr/>
           <p:nvPr/>
         </p:nvGrpSpPr>
         <p:grpSpPr>
           <a:xfrm rot="0">
-            <a:off x="1124712" y="2653760"/>
+            <a:off x="1124712" y="2694118"/>
             <a:ext cx="822960" cy="418624"/>
             <a:chOff x="0" y="0"/>
             <a:chExt cx="1097280" cy="558165"/>
@@ -38340,7 +38340,7 @@
         </p:grpSpPr>
         <p:sp>
           <p:nvSpPr>
-            <p:cNvPr name="Freeform 46" id="46"/>
+            <p:cNvPr name="Freeform 46" id="405"/>
             <p:cNvSpPr/>
             <p:nvPr/>
           </p:nvSpPr>
@@ -38385,7 +38385,7 @@
         </p:sp>
         <p:sp>
           <p:nvSpPr>
-            <p:cNvPr name="TextBox 47" id="47"/>
+            <p:cNvPr name="TextBox 47" id="406"/>
             <p:cNvSpPr txBox="true"/>
             <p:nvPr/>
           </p:nvSpPr>
@@ -38423,201 +38423,41 @@
           </p:txBody>
         </p:sp>
       </p:grpSp>
-      <p:grpSp>
-        <p:nvGrpSpPr>
-          <p:cNvPr name="Group 48" id="48"/>
-          <p:cNvGrpSpPr/>
-          <p:nvPr/>
-        </p:nvGrpSpPr>
-        <p:grpSpPr>
-          <a:xfrm rot="0">
-            <a:off x="2057400" y="2633472"/>
-            <a:ext cx="7749540" cy="431111"/>
-            <a:chOff x="0" y="0"/>
-            <a:chExt cx="10332720" cy="574815"/>
-          </a:xfrm>
-        </p:grpSpPr>
-        <p:sp>
-          <p:nvSpPr>
-            <p:cNvPr name="Freeform 49" id="49"/>
-            <p:cNvSpPr/>
-            <p:nvPr/>
-          </p:nvSpPr>
-          <p:spPr>
-            <a:xfrm flipH="false" flipV="false" rot="0">
-              <a:off x="0" y="0"/>
-              <a:ext cx="10332720" cy="574802"/>
-            </a:xfrm>
-            <a:custGeom>
-              <a:avLst/>
-              <a:gdLst/>
-              <a:ahLst/>
-              <a:cxnLst/>
-              <a:rect r="r" b="b" t="t" l="l"/>
-              <a:pathLst>
-                <a:path h="574802" w="10332720">
-                  <a:moveTo>
-                    <a:pt x="0" y="0"/>
-                  </a:moveTo>
-                  <a:lnTo>
-                    <a:pt x="10332720" y="0"/>
-                  </a:lnTo>
-                  <a:lnTo>
-                    <a:pt x="10332720" y="574802"/>
-                  </a:lnTo>
-                  <a:lnTo>
-                    <a:pt x="0" y="574802"/>
-                  </a:lnTo>
-                  <a:close/>
-                </a:path>
-              </a:pathLst>
-            </a:custGeom>
-            <a:blipFill>
-              <a:blip r:embed="rId3">
-                <a:alphaModFix amt="0"/>
-              </a:blip>
-              <a:stretch>
-                <a:fillRect l="0" t="-300019" r="0" b="-300024"/>
-              </a:stretch>
-            </a:blipFill>
-          </p:spPr>
-        </p:sp>
-      </p:grpSp>
-      <p:grpSp>
-        <p:nvGrpSpPr>
-          <p:cNvPr name="Group 50" id="50"/>
-          <p:cNvGrpSpPr/>
-          <p:nvPr/>
-        </p:nvGrpSpPr>
-        <p:grpSpPr>
-          <a:xfrm rot="0">
-            <a:off x="2057400" y="2597753"/>
-            <a:ext cx="7749540" cy="466830"/>
-            <a:chOff x="0" y="0"/>
-            <a:chExt cx="10332720" cy="622440"/>
-          </a:xfrm>
-        </p:grpSpPr>
-        <p:sp>
-          <p:nvSpPr>
-            <p:cNvPr name="Freeform 51" id="51"/>
-            <p:cNvSpPr/>
-            <p:nvPr/>
-          </p:nvSpPr>
-          <p:spPr>
-            <a:xfrm flipH="false" flipV="false" rot="0">
-              <a:off x="0" y="0"/>
-              <a:ext cx="10332720" cy="622442"/>
-            </a:xfrm>
-            <a:custGeom>
-              <a:avLst/>
-              <a:gdLst/>
-              <a:ahLst/>
-              <a:cxnLst/>
-              <a:rect r="r" b="b" t="t" l="l"/>
-              <a:pathLst>
-                <a:path h="622442" w="10332720">
-                  <a:moveTo>
-                    <a:pt x="0" y="0"/>
-                  </a:moveTo>
-                  <a:lnTo>
-                    <a:pt x="10332720" y="0"/>
-                  </a:lnTo>
-                  <a:lnTo>
-                    <a:pt x="10332720" y="622442"/>
-                  </a:lnTo>
-                  <a:lnTo>
-                    <a:pt x="0" y="622442"/>
-                  </a:lnTo>
-                  <a:close/>
-                </a:path>
-              </a:pathLst>
-            </a:custGeom>
-            <a:blipFill>
-              <a:blip r:embed="rId4">
-                <a:alphaModFix amt="0"/>
-              </a:blip>
-              <a:stretch>
-                <a:fillRect l="0" t="-273457" r="0" b="-273456"/>
-              </a:stretch>
-            </a:blipFill>
-          </p:spPr>
-        </p:sp>
-        <p:sp>
-          <p:nvSpPr>
-            <p:cNvPr name="TextBox 52" id="52"/>
-            <p:cNvSpPr txBox="true"/>
-            <p:nvPr/>
-          </p:nvSpPr>
-          <p:spPr>
-            <a:xfrm>
-              <a:off x="0" y="-57150"/>
-              <a:ext cx="10332720" cy="679590"/>
-            </a:xfrm>
-            <a:prstGeom prst="rect">
-              <a:avLst/>
-            </a:prstGeom>
-          </p:spPr>
-          <p:txBody>
-            <a:bodyPr anchor="ctr" rtlCol="false" tIns="0" lIns="0" bIns="0" rIns="0"/>
-            <a:lstStyle/>
-            <a:p>
-              <a:pPr algn="l">
-                <a:lnSpc>
-                  <a:spcPts val="2608"/>
-                </a:lnSpc>
-              </a:pPr>
-              <a:r>
-                <a:rPr sz="2000" b="1" i="0">
-                  <a:solidFill>
-                    <a:srgbClr val="1F497D"/>
-                  </a:solidFill>
-                  <a:latin typeface="Calibri"/>
-                </a:rPr>
-                <a:t>IIT Jodhpur &amp; Manipal Univ. (IEEE Access, Sept 2026) [1]</a:t>
-              </a:r>
-            </a:p>
-          </p:txBody>
-        </p:sp>
-      </p:grpSp>
       <p:sp>
         <p:nvSpPr>
-          <p:cNvPr name="TextBox 53" id="53"/>
-          <p:cNvSpPr txBox="true"/>
+          <p:cNvPr id="407" name="ResearchCard_Text_01"/>
+          <p:cNvSpPr txBox="1"/>
           <p:nvPr/>
         </p:nvSpPr>
         <p:spPr>
-          <a:xfrm rot="0">
-            <a:off x="2057400" y="2968752"/>
-            <a:ext cx="7749540" cy="922094"/>
+          <a:xfrm>
+            <a:off x="2029968" y="2584390"/>
+            <a:ext cx="7818120" cy="896112"/>
           </a:xfrm>
           <a:prstGeom prst="rect">
             <a:avLst/>
           </a:prstGeom>
+          <a:noFill/>
         </p:spPr>
         <p:txBody>
-          <a:bodyPr anchor="t" rtlCol="false" tIns="0" lIns="0" bIns="0" rIns="0">
+          <a:bodyPr wrap="square" lIns="0" rIns="0" tIns="0" bIns="0">
             <a:spAutoFit/>
           </a:bodyPr>
           <a:lstStyle/>
           <a:p>
-            <a:pPr algn="l" marL="330279" indent="-110093" lvl="2">
-              <a:lnSpc>
-                <a:spcPts val="1980"/>
-              </a:lnSpc>
+            <a:pPr>
               <a:spcAft>
                 <a:spcPts val="200"/>
               </a:spcAft>
-              <a:buFont typeface="Arial"/>
-              <a:buChar char="⚬"/>
+              <a:defRPr sz="1300" b="1">
+                <a:solidFill>
+                  <a:srgbClr val="1F497D"/>
+                </a:solidFill>
+                <a:latin typeface="Calibri"/>
+              </a:defRPr>
             </a:pPr>
             <a:r>
-              <a:rPr sz="1450" b="0" i="0">
-                <a:solidFill>
-                  <a:srgbClr val="566074"/>
-                </a:solidFill>
-                <a:latin typeface="Calibri"/>
-              </a:rPr>
-              <a:t>• 'SwarmSAR-FW: Drone-Based Swarm Search and Rescue in Fire and Water Disasters'</a:t>
+              <a:t>IIT Jodhpur &amp; Manipal Univ. (IEEE Access, Sept 2026) [1]</a:t>
             </a:r>
           </a:p>
           <a:p>
@@ -38625,9 +38465,20 @@
               <a:spcAft>
                 <a:spcPts val="200"/>
               </a:spcAft>
+              <a:defRPr sz="1050" i="1">
+                <a:solidFill>
+                  <a:srgbClr val="566074"/>
+                </a:solidFill>
+                <a:latin typeface="Calibri"/>
+              </a:defRPr>
             </a:pPr>
             <a:r>
-              <a:rPr sz="1450" b="1" i="0">
+              <a:t>• "SwarmSAR-FW: Drone-Based Swarm Search &amp; Rescue in Fire and Water Disasters"</a:t>
+            </a:r>
+          </a:p>
+          <a:p>
+            <a:r>
+              <a:rPr sz="950" b="1">
                 <a:solidFill>
                   <a:srgbClr val="1E2638"/>
                 </a:solidFill>
@@ -38636,18 +38487,16 @@
               <a:t>• HAZARD-AWARE DIJKSTRA ROUTING: </a:t>
             </a:r>
             <a:r>
-              <a:rPr sz="1450" b="0" i="0">
+              <a:rPr sz="950">
                 <a:solidFill>
                   <a:srgbClr val="3C465A"/>
                 </a:solidFill>
                 <a:latin typeface="Calibri"/>
               </a:rPr>
-              <a:t>Validates safe ingress routing (98.7% triage accuracy, 4.1s) avoiding debris &amp; power lines.</a:t>
+              <a:t>Validates safe ingress routing (98.7% triage accuracy, 4.1s) avoiding obstacles. | </a:t>
             </a:r>
-          </a:p>
-          <a:p>
             <a:r>
-              <a:rPr sz="1200" b="1" i="0">
+              <a:rPr sz="950" b="1">
                 <a:solidFill>
                   <a:srgbClr val="B35A00"/>
                 </a:solidFill>
@@ -38656,27 +38505,28 @@
               <a:t>DOI: </a:t>
             </a:r>
             <a:r>
-              <a:rPr sz="1200" b="0" i="0">
+              <a:rPr sz="950">
                 <a:solidFill>
                   <a:srgbClr val="0000FF"/>
                 </a:solidFill>
                 <a:latin typeface="Calibri"/>
+                <a:hlinkClick r:id="rId9"/>
               </a:rPr>
-              <a:t>10.1109/ACCESS.2026.3730315 (Direct IEEE Document Link)</a:t>
+              <a:t>10.1109/ACCESS.2026.3730315</a:t>
             </a:r>
           </a:p>
         </p:txBody>
       </p:sp>
       <p:sp>
         <p:nvSpPr>
-          <p:cNvPr name="Freeform 54" id="54"/>
+          <p:cNvPr name="ResearchCard_BG_02" id="408"/>
           <p:cNvSpPr/>
           <p:nvPr/>
         </p:nvSpPr>
         <p:spPr>
           <a:xfrm flipH="false" flipV="false" rot="0">
-            <a:off x="810454" y="4212022"/>
-            <a:ext cx="9283303" cy="1561195"/>
+            <a:off x="810454" y="3634011"/>
+            <a:ext cx="9283303" cy="1049621"/>
           </a:xfrm>
           <a:custGeom>
             <a:avLst/>
@@ -38685,7 +38535,7 @@
             <a:cxnLst/>
             <a:rect r="r" b="b" t="t" l="l"/>
             <a:pathLst>
-              <a:path h="1561195" w="9283303">
+              <a:path h="1049621" w="9283303">
                 <a:moveTo>
                   <a:pt x="0" y="0"/>
                 </a:moveTo>
@@ -38693,10 +38543,10 @@
                   <a:pt x="9283303" y="0"/>
                 </a:lnTo>
                 <a:lnTo>
-                  <a:pt x="9283303" y="1561195"/>
+                  <a:pt x="9283303" y="1049621"/>
                 </a:lnTo>
                 <a:lnTo>
-                  <a:pt x="0" y="1561195"/>
+                  <a:pt x="0" y="1049621"/>
                 </a:lnTo>
                 <a:lnTo>
                   <a:pt x="0" y="0"/>
@@ -38721,13 +38571,13 @@
       </p:sp>
       <p:grpSp>
         <p:nvGrpSpPr>
-          <p:cNvPr name="Group 55" id="55"/>
+          <p:cNvPr name="BadgeShadow_02" id="409"/>
           <p:cNvGrpSpPr/>
           <p:nvPr/>
         </p:nvGrpSpPr>
         <p:grpSpPr>
           <a:xfrm rot="0">
-            <a:off x="1124712" y="4361688"/>
+            <a:off x="1124712" y="3824035"/>
             <a:ext cx="822960" cy="411480"/>
             <a:chOff x="0" y="0"/>
             <a:chExt cx="1097280" cy="548640"/>
@@ -38735,7 +38585,7 @@
         </p:grpSpPr>
         <p:sp>
           <p:nvSpPr>
-            <p:cNvPr name="Freeform 56" id="56"/>
+            <p:cNvPr name="Freeform 44" id="410"/>
             <p:cNvSpPr/>
             <p:nvPr/>
           </p:nvSpPr>
@@ -38781,13 +38631,13 @@
       </p:grpSp>
       <p:grpSp>
         <p:nvGrpSpPr>
-          <p:cNvPr name="Group 57" id="57"/>
+          <p:cNvPr name="BadgeGroup_02" id="411"/>
           <p:cNvGrpSpPr/>
           <p:nvPr/>
         </p:nvGrpSpPr>
         <p:grpSpPr>
           <a:xfrm rot="0">
-            <a:off x="1124712" y="4354544"/>
+            <a:off x="1124712" y="3816891"/>
             <a:ext cx="822960" cy="418624"/>
             <a:chOff x="0" y="0"/>
             <a:chExt cx="1097280" cy="558165"/>
@@ -38795,7 +38645,7 @@
         </p:grpSpPr>
         <p:sp>
           <p:nvSpPr>
-            <p:cNvPr name="Freeform 58" id="58"/>
+            <p:cNvPr name="Freeform 46" id="412"/>
             <p:cNvSpPr/>
             <p:nvPr/>
           </p:nvSpPr>
@@ -38840,7 +38690,7 @@
         </p:sp>
         <p:sp>
           <p:nvSpPr>
-            <p:cNvPr name="TextBox 59" id="59"/>
+            <p:cNvPr name="TextBox 47" id="413"/>
             <p:cNvSpPr txBox="true"/>
             <p:nvPr/>
           </p:nvSpPr>
@@ -38878,201 +38728,41 @@
           </p:txBody>
         </p:sp>
       </p:grpSp>
-      <p:grpSp>
-        <p:nvGrpSpPr>
-          <p:cNvPr name="Group 60" id="60"/>
-          <p:cNvGrpSpPr/>
-          <p:nvPr/>
-        </p:nvGrpSpPr>
-        <p:grpSpPr>
-          <a:xfrm rot="0">
-            <a:off x="2057400" y="4334256"/>
-            <a:ext cx="7749540" cy="431111"/>
-            <a:chOff x="0" y="0"/>
-            <a:chExt cx="10332720" cy="574815"/>
-          </a:xfrm>
-        </p:grpSpPr>
-        <p:sp>
-          <p:nvSpPr>
-            <p:cNvPr name="Freeform 61" id="61"/>
-            <p:cNvSpPr/>
-            <p:nvPr/>
-          </p:nvSpPr>
-          <p:spPr>
-            <a:xfrm flipH="false" flipV="false" rot="0">
-              <a:off x="0" y="0"/>
-              <a:ext cx="10332720" cy="574802"/>
-            </a:xfrm>
-            <a:custGeom>
-              <a:avLst/>
-              <a:gdLst/>
-              <a:ahLst/>
-              <a:cxnLst/>
-              <a:rect r="r" b="b" t="t" l="l"/>
-              <a:pathLst>
-                <a:path h="574802" w="10332720">
-                  <a:moveTo>
-                    <a:pt x="0" y="0"/>
-                  </a:moveTo>
-                  <a:lnTo>
-                    <a:pt x="10332720" y="0"/>
-                  </a:lnTo>
-                  <a:lnTo>
-                    <a:pt x="10332720" y="574802"/>
-                  </a:lnTo>
-                  <a:lnTo>
-                    <a:pt x="0" y="574802"/>
-                  </a:lnTo>
-                  <a:close/>
-                </a:path>
-              </a:pathLst>
-            </a:custGeom>
-            <a:blipFill>
-              <a:blip r:embed="rId3">
-                <a:alphaModFix amt="0"/>
-              </a:blip>
-              <a:stretch>
-                <a:fillRect l="0" t="-300019" r="0" b="-300024"/>
-              </a:stretch>
-            </a:blipFill>
-          </p:spPr>
-        </p:sp>
-      </p:grpSp>
-      <p:grpSp>
-        <p:nvGrpSpPr>
-          <p:cNvPr name="Group 62" id="62"/>
-          <p:cNvGrpSpPr/>
-          <p:nvPr/>
-        </p:nvGrpSpPr>
-        <p:grpSpPr>
-          <a:xfrm rot="0">
-            <a:off x="2057400" y="4298537"/>
-            <a:ext cx="7749540" cy="466830"/>
-            <a:chOff x="0" y="0"/>
-            <a:chExt cx="10332720" cy="622440"/>
-          </a:xfrm>
-        </p:grpSpPr>
-        <p:sp>
-          <p:nvSpPr>
-            <p:cNvPr name="Freeform 63" id="63"/>
-            <p:cNvSpPr/>
-            <p:nvPr/>
-          </p:nvSpPr>
-          <p:spPr>
-            <a:xfrm flipH="false" flipV="false" rot="0">
-              <a:off x="0" y="0"/>
-              <a:ext cx="10332720" cy="622442"/>
-            </a:xfrm>
-            <a:custGeom>
-              <a:avLst/>
-              <a:gdLst/>
-              <a:ahLst/>
-              <a:cxnLst/>
-              <a:rect r="r" b="b" t="t" l="l"/>
-              <a:pathLst>
-                <a:path h="622442" w="10332720">
-                  <a:moveTo>
-                    <a:pt x="0" y="0"/>
-                  </a:moveTo>
-                  <a:lnTo>
-                    <a:pt x="10332720" y="0"/>
-                  </a:lnTo>
-                  <a:lnTo>
-                    <a:pt x="10332720" y="622442"/>
-                  </a:lnTo>
-                  <a:lnTo>
-                    <a:pt x="0" y="622442"/>
-                  </a:lnTo>
-                  <a:close/>
-                </a:path>
-              </a:pathLst>
-            </a:custGeom>
-            <a:blipFill>
-              <a:blip r:embed="rId4">
-                <a:alphaModFix amt="0"/>
-              </a:blip>
-              <a:stretch>
-                <a:fillRect l="0" t="-273457" r="0" b="-273456"/>
-              </a:stretch>
-            </a:blipFill>
-          </p:spPr>
-        </p:sp>
-        <p:sp>
-          <p:nvSpPr>
-            <p:cNvPr name="TextBox 64" id="64"/>
-            <p:cNvSpPr txBox="true"/>
-            <p:nvPr/>
-          </p:nvSpPr>
-          <p:spPr>
-            <a:xfrm>
-              <a:off x="0" y="-57150"/>
-              <a:ext cx="10332720" cy="679590"/>
-            </a:xfrm>
-            <a:prstGeom prst="rect">
-              <a:avLst/>
-            </a:prstGeom>
-          </p:spPr>
-          <p:txBody>
-            <a:bodyPr anchor="ctr" rtlCol="false" tIns="0" lIns="0" bIns="0" rIns="0"/>
-            <a:lstStyle/>
-            <a:p>
-              <a:pPr algn="l">
-                <a:lnSpc>
-                  <a:spcPts val="2609"/>
-                </a:lnSpc>
-              </a:pPr>
-              <a:r>
-                <a:rPr sz="2000" b="1" i="0">
-                  <a:solidFill>
-                    <a:srgbClr val="1F497D"/>
-                  </a:solidFill>
-                  <a:latin typeface="Calibri"/>
-                </a:rPr>
-                <a:t>UPC Spain &amp; Souli et al. (IEEE Access 2026 / Elsevier 2024) [2, 3]</a:t>
-              </a:r>
-            </a:p>
-          </p:txBody>
-        </p:sp>
-      </p:grpSp>
       <p:sp>
         <p:nvSpPr>
-          <p:cNvPr name="TextBox 65" id="65"/>
-          <p:cNvSpPr txBox="true"/>
+          <p:cNvPr id="414" name="ResearchCard_Text_02"/>
+          <p:cNvSpPr txBox="1"/>
           <p:nvPr/>
         </p:nvSpPr>
         <p:spPr>
-          <a:xfrm rot="0">
-            <a:off x="2057400" y="4660011"/>
-            <a:ext cx="7749540" cy="937204"/>
+          <a:xfrm>
+            <a:off x="2029968" y="3707163"/>
+            <a:ext cx="7818120" cy="896112"/>
           </a:xfrm>
           <a:prstGeom prst="rect">
             <a:avLst/>
           </a:prstGeom>
+          <a:noFill/>
         </p:spPr>
         <p:txBody>
-          <a:bodyPr anchor="t" rtlCol="false" tIns="0" lIns="0" bIns="0" rIns="0">
+          <a:bodyPr wrap="square" lIns="0" rIns="0" tIns="0" bIns="0">
             <a:spAutoFit/>
           </a:bodyPr>
           <a:lstStyle/>
           <a:p>
-            <a:pPr algn="l" marL="324247" indent="-108082" lvl="2">
-              <a:lnSpc>
-                <a:spcPts val="1980"/>
-              </a:lnSpc>
+            <a:pPr>
               <a:spcAft>
                 <a:spcPts val="200"/>
               </a:spcAft>
-              <a:buFont typeface="Arial"/>
-              <a:buChar char="⚬"/>
+              <a:defRPr sz="1300" b="1">
+                <a:solidFill>
+                  <a:srgbClr val="1F497D"/>
+                </a:solidFill>
+                <a:latin typeface="Calibri"/>
+              </a:defRPr>
             </a:pPr>
             <a:r>
-              <a:rPr sz="1450" b="0" i="0">
-                <a:solidFill>
-                  <a:srgbClr val="566074"/>
-                </a:solidFill>
-                <a:latin typeface="Calibri"/>
-              </a:rPr>
-              <a:t>• 'Long-Range BLE via Drone LoRa Relays' [2] &amp; 'Mission-Critical ROS-LoRa Architecture' [3]</a:t>
+              <a:t>UPC Barcelona (IEEE Access, Sept 2026) [2]</a:t>
             </a:r>
           </a:p>
           <a:p>
@@ -39080,58 +38770,68 @@
               <a:spcAft>
                 <a:spcPts val="200"/>
               </a:spcAft>
+              <a:defRPr sz="1050" i="1">
+                <a:solidFill>
+                  <a:srgbClr val="566074"/>
+                </a:solidFill>
+                <a:latin typeface="Calibri"/>
+              </a:defRPr>
             </a:pPr>
             <a:r>
-              <a:rPr sz="1450" b="1" i="0">
+              <a:t>• "Long-Range BLE Localization via Drone LoRa Relays for SAR Missions"</a:t>
+            </a:r>
+          </a:p>
+          <a:p>
+            <a:r>
+              <a:rPr sz="950" b="1">
                 <a:solidFill>
                   <a:srgbClr val="1E2638"/>
                 </a:solidFill>
                 <a:latin typeface="Calibri"/>
               </a:rPr>
-              <a:t>• 868 MHZ LORA &amp; 17-BYTE TELEMETRY: </a:t>
+              <a:t>• 868 MHZ LORA NLoS CANYON RELAY: </a:t>
             </a:r>
             <a:r>
-              <a:rPr sz="1450" b="0" i="0">
+              <a:rPr sz="950">
                 <a:solidFill>
                   <a:srgbClr val="3C465A"/>
                 </a:solidFill>
                 <a:latin typeface="Calibri"/>
               </a:rPr>
-              <a:t>Validates off-grid NLoS canyon relay and 17-byte bit-packed triage frames during blackouts.</a:t>
+              <a:t>Validates off-grid BLE-to-LoRa payload forwarding across deep terrain. | </a:t>
             </a:r>
-          </a:p>
-          <a:p>
             <a:r>
-              <a:rPr sz="1200" b="1" i="0">
+              <a:rPr sz="950" b="1">
                 <a:solidFill>
                   <a:srgbClr val="B35A00"/>
                 </a:solidFill>
                 <a:latin typeface="Calibri"/>
               </a:rPr>
-              <a:t>DOIs: </a:t>
+              <a:t>DOI: </a:t>
             </a:r>
             <a:r>
-              <a:rPr sz="1200" b="0" i="0">
+              <a:rPr sz="950">
                 <a:solidFill>
                   <a:srgbClr val="0000FF"/>
                 </a:solidFill>
                 <a:latin typeface="Calibri"/>
+                <a:hlinkClick r:id="rId10"/>
               </a:rPr>
-              <a:t>10.1109/ACCESS.2026.3731317 [2]  |  10.1016/j.comcom.2024.04.015 [3]</a:t>
+              <a:t>10.1109/ACCESS.2026.3731317</a:t>
             </a:r>
           </a:p>
         </p:txBody>
       </p:sp>
       <p:sp>
         <p:nvSpPr>
-          <p:cNvPr name="Freeform 66" id="66"/>
+          <p:cNvPr name="ResearchCard_BG_03" id="415"/>
           <p:cNvSpPr/>
           <p:nvPr/>
         </p:nvSpPr>
         <p:spPr>
           <a:xfrm flipH="false" flipV="false" rot="0">
-            <a:off x="810454" y="5912806"/>
-            <a:ext cx="9283303" cy="1561195"/>
+            <a:off x="810454" y="4756784"/>
+            <a:ext cx="9283303" cy="1049621"/>
           </a:xfrm>
           <a:custGeom>
             <a:avLst/>
@@ -39140,7 +38840,7 @@
             <a:cxnLst/>
             <a:rect r="r" b="b" t="t" l="l"/>
             <a:pathLst>
-              <a:path h="1561195" w="9283303">
+              <a:path h="1049621" w="9283303">
                 <a:moveTo>
                   <a:pt x="0" y="0"/>
                 </a:moveTo>
@@ -39148,10 +38848,10 @@
                   <a:pt x="9283303" y="0"/>
                 </a:lnTo>
                 <a:lnTo>
-                  <a:pt x="9283303" y="1561195"/>
+                  <a:pt x="9283303" y="1049621"/>
                 </a:lnTo>
                 <a:lnTo>
-                  <a:pt x="0" y="1561195"/>
+                  <a:pt x="0" y="1049621"/>
                 </a:lnTo>
                 <a:lnTo>
                   <a:pt x="0" y="0"/>
@@ -39176,13 +38876,13 @@
       </p:sp>
       <p:grpSp>
         <p:nvGrpSpPr>
-          <p:cNvPr name="Group 67" id="67"/>
+          <p:cNvPr name="BadgeShadow_03" id="416"/>
           <p:cNvGrpSpPr/>
           <p:nvPr/>
         </p:nvGrpSpPr>
         <p:grpSpPr>
           <a:xfrm rot="0">
-            <a:off x="1124712" y="6062472"/>
+            <a:off x="1124712" y="4946808"/>
             <a:ext cx="822960" cy="411480"/>
             <a:chOff x="0" y="0"/>
             <a:chExt cx="1097280" cy="548640"/>
@@ -39190,7 +38890,7 @@
         </p:grpSpPr>
         <p:sp>
           <p:nvSpPr>
-            <p:cNvPr name="Freeform 68" id="68"/>
+            <p:cNvPr name="Freeform 44" id="417"/>
             <p:cNvSpPr/>
             <p:nvPr/>
           </p:nvSpPr>
@@ -39236,13 +38936,13 @@
       </p:grpSp>
       <p:grpSp>
         <p:nvGrpSpPr>
-          <p:cNvPr name="Group 69" id="69"/>
+          <p:cNvPr name="BadgeGroup_03" id="418"/>
           <p:cNvGrpSpPr/>
           <p:nvPr/>
         </p:nvGrpSpPr>
         <p:grpSpPr>
           <a:xfrm rot="0">
-            <a:off x="1124712" y="6055328"/>
+            <a:off x="1124712" y="4939664"/>
             <a:ext cx="822960" cy="418624"/>
             <a:chOff x="0" y="0"/>
             <a:chExt cx="1097280" cy="558165"/>
@@ -39250,7 +38950,7 @@
         </p:grpSpPr>
         <p:sp>
           <p:nvSpPr>
-            <p:cNvPr name="Freeform 70" id="70"/>
+            <p:cNvPr name="Freeform 46" id="419"/>
             <p:cNvSpPr/>
             <p:nvPr/>
           </p:nvSpPr>
@@ -39295,7 +38995,7 @@
         </p:sp>
         <p:sp>
           <p:nvSpPr>
-            <p:cNvPr name="TextBox 71" id="71"/>
+            <p:cNvPr name="TextBox 47" id="420"/>
             <p:cNvSpPr txBox="true"/>
             <p:nvPr/>
           </p:nvSpPr>
@@ -39333,201 +39033,41 @@
           </p:txBody>
         </p:sp>
       </p:grpSp>
-      <p:grpSp>
-        <p:nvGrpSpPr>
-          <p:cNvPr name="Group 72" id="72"/>
-          <p:cNvGrpSpPr/>
-          <p:nvPr/>
-        </p:nvGrpSpPr>
-        <p:grpSpPr>
-          <a:xfrm rot="0">
-            <a:off x="2057400" y="6035040"/>
-            <a:ext cx="7749540" cy="431111"/>
-            <a:chOff x="0" y="0"/>
-            <a:chExt cx="10332720" cy="574815"/>
-          </a:xfrm>
-        </p:grpSpPr>
-        <p:sp>
-          <p:nvSpPr>
-            <p:cNvPr name="Freeform 73" id="73"/>
-            <p:cNvSpPr/>
-            <p:nvPr/>
-          </p:nvSpPr>
-          <p:spPr>
-            <a:xfrm flipH="false" flipV="false" rot="0">
-              <a:off x="0" y="0"/>
-              <a:ext cx="10332720" cy="574802"/>
-            </a:xfrm>
-            <a:custGeom>
-              <a:avLst/>
-              <a:gdLst/>
-              <a:ahLst/>
-              <a:cxnLst/>
-              <a:rect r="r" b="b" t="t" l="l"/>
-              <a:pathLst>
-                <a:path h="574802" w="10332720">
-                  <a:moveTo>
-                    <a:pt x="0" y="0"/>
-                  </a:moveTo>
-                  <a:lnTo>
-                    <a:pt x="10332720" y="0"/>
-                  </a:lnTo>
-                  <a:lnTo>
-                    <a:pt x="10332720" y="574802"/>
-                  </a:lnTo>
-                  <a:lnTo>
-                    <a:pt x="0" y="574802"/>
-                  </a:lnTo>
-                  <a:close/>
-                </a:path>
-              </a:pathLst>
-            </a:custGeom>
-            <a:blipFill>
-              <a:blip r:embed="rId3">
-                <a:alphaModFix amt="0"/>
-              </a:blip>
-              <a:stretch>
-                <a:fillRect l="0" t="-300019" r="0" b="-300024"/>
-              </a:stretch>
-            </a:blipFill>
-          </p:spPr>
-        </p:sp>
-      </p:grpSp>
-      <p:grpSp>
-        <p:nvGrpSpPr>
-          <p:cNvPr name="Group 74" id="74"/>
-          <p:cNvGrpSpPr/>
-          <p:nvPr/>
-        </p:nvGrpSpPr>
-        <p:grpSpPr>
-          <a:xfrm rot="0">
-            <a:off x="2057400" y="5999321"/>
-            <a:ext cx="7749540" cy="466830"/>
-            <a:chOff x="0" y="0"/>
-            <a:chExt cx="10332720" cy="622440"/>
-          </a:xfrm>
-        </p:grpSpPr>
-        <p:sp>
-          <p:nvSpPr>
-            <p:cNvPr name="Freeform 75" id="75"/>
-            <p:cNvSpPr/>
-            <p:nvPr/>
-          </p:nvSpPr>
-          <p:spPr>
-            <a:xfrm flipH="false" flipV="false" rot="0">
-              <a:off x="0" y="0"/>
-              <a:ext cx="10332720" cy="622442"/>
-            </a:xfrm>
-            <a:custGeom>
-              <a:avLst/>
-              <a:gdLst/>
-              <a:ahLst/>
-              <a:cxnLst/>
-              <a:rect r="r" b="b" t="t" l="l"/>
-              <a:pathLst>
-                <a:path h="622442" w="10332720">
-                  <a:moveTo>
-                    <a:pt x="0" y="0"/>
-                  </a:moveTo>
-                  <a:lnTo>
-                    <a:pt x="10332720" y="0"/>
-                  </a:lnTo>
-                  <a:lnTo>
-                    <a:pt x="10332720" y="622442"/>
-                  </a:lnTo>
-                  <a:lnTo>
-                    <a:pt x="0" y="622442"/>
-                  </a:lnTo>
-                  <a:close/>
-                </a:path>
-              </a:pathLst>
-            </a:custGeom>
-            <a:blipFill>
-              <a:blip r:embed="rId4">
-                <a:alphaModFix amt="0"/>
-              </a:blip>
-              <a:stretch>
-                <a:fillRect l="0" t="-273457" r="0" b="-273456"/>
-              </a:stretch>
-            </a:blipFill>
-          </p:spPr>
-        </p:sp>
-        <p:sp>
-          <p:nvSpPr>
-            <p:cNvPr name="TextBox 76" id="76"/>
-            <p:cNvSpPr txBox="true"/>
-            <p:nvPr/>
-          </p:nvSpPr>
-          <p:spPr>
-            <a:xfrm>
-              <a:off x="0" y="-57150"/>
-              <a:ext cx="10332720" cy="679590"/>
-            </a:xfrm>
-            <a:prstGeom prst="rect">
-              <a:avLst/>
-            </a:prstGeom>
-          </p:spPr>
-          <p:txBody>
-            <a:bodyPr anchor="ctr" rtlCol="false" tIns="0" lIns="0" bIns="0" rIns="0"/>
-            <a:lstStyle/>
-            <a:p>
-              <a:pPr algn="l">
-                <a:lnSpc>
-                  <a:spcPts val="2609"/>
-                </a:lnSpc>
-              </a:pPr>
-              <a:r>
-                <a:rPr sz="2000" b="1" i="0">
-                  <a:solidFill>
-                    <a:srgbClr val="1F497D"/>
-                  </a:solidFill>
-                  <a:latin typeface="Calibri"/>
-                </a:rPr>
-                <a:t>TalTech Estonia (IEEE Access, July 2023) [4]</a:t>
-              </a:r>
-            </a:p>
-          </p:txBody>
-        </p:sp>
-      </p:grpSp>
       <p:sp>
         <p:nvSpPr>
-          <p:cNvPr name="TextBox 77" id="77"/>
-          <p:cNvSpPr txBox="true"/>
+          <p:cNvPr id="421" name="ResearchCard_Text_03"/>
+          <p:cNvSpPr txBox="1"/>
           <p:nvPr/>
         </p:nvSpPr>
         <p:spPr>
-          <a:xfrm rot="0">
-            <a:off x="2057400" y="6360795"/>
-            <a:ext cx="7749540" cy="908648"/>
+          <a:xfrm>
+            <a:off x="2029968" y="4829936"/>
+            <a:ext cx="7818120" cy="896112"/>
           </a:xfrm>
           <a:prstGeom prst="rect">
             <a:avLst/>
           </a:prstGeom>
+          <a:noFill/>
         </p:spPr>
         <p:txBody>
-          <a:bodyPr anchor="t" rtlCol="false" tIns="0" lIns="0" bIns="0" rIns="0">
+          <a:bodyPr wrap="square" lIns="0" rIns="0" tIns="0" bIns="0">
             <a:spAutoFit/>
           </a:bodyPr>
           <a:lstStyle/>
           <a:p>
-            <a:pPr algn="l" marL="324247" indent="-108082" lvl="2">
-              <a:lnSpc>
-                <a:spcPts val="1980"/>
-              </a:lnSpc>
+            <a:pPr>
               <a:spcAft>
                 <a:spcPts val="200"/>
               </a:spcAft>
-              <a:buFont typeface="Arial"/>
-              <a:buChar char="⚬"/>
+              <a:defRPr sz="1300" b="1">
+                <a:solidFill>
+                  <a:srgbClr val="1F497D"/>
+                </a:solidFill>
+                <a:latin typeface="Calibri"/>
+              </a:defRPr>
             </a:pPr>
             <a:r>
-              <a:rPr sz="1450" b="0" i="0">
-                <a:solidFill>
-                  <a:srgbClr val="566074"/>
-                </a:solidFill>
-                <a:latin typeface="Calibri"/>
-              </a:rPr>
-              <a:t>• 'Applying RIS-Based Communication for Collaborative Computing in a Swarm of Drones'</a:t>
+              <a:t>Univ. of Cyprus &amp; KIOS CoE (Elsevier Computer Communications, 2024) [3]</a:t>
             </a:r>
           </a:p>
           <a:p>
@@ -39535,29 +39075,38 @@
               <a:spcAft>
                 <a:spcPts val="200"/>
               </a:spcAft>
+              <a:defRPr sz="1050" i="1">
+                <a:solidFill>
+                  <a:srgbClr val="566074"/>
+                </a:solidFill>
+                <a:latin typeface="Calibri"/>
+              </a:defRPr>
             </a:pPr>
             <a:r>
-              <a:rPr sz="1450" b="1" i="0">
+              <a:t>• "Mission-Critical ROS-LoRa Architecture for Autonomous Drone Search &amp; Rescue"</a:t>
+            </a:r>
+          </a:p>
+          <a:p>
+            <a:r>
+              <a:rPr sz="950" b="1">
                 <a:solidFill>
                   <a:srgbClr val="1E2638"/>
                 </a:solidFill>
                 <a:latin typeface="Calibri"/>
               </a:rPr>
-              <a:t>• DECENTRALIZED EDGE COMPUTE: </a:t>
+              <a:t>• 17-BYTE COMPACT TELEMETRY: </a:t>
             </a:r>
             <a:r>
-              <a:rPr sz="1450" b="0" i="0">
+              <a:rPr sz="950">
                 <a:solidFill>
                   <a:srgbClr val="3C465A"/>
                 </a:solidFill>
                 <a:latin typeface="Calibri"/>
               </a:rPr>
-              <a:t>Validates autonomous on-device computing (-32% energy, -18% latency) with zero cloud reliance.</a:t>
+              <a:t>Validates ultra-low-bandwidth bit-packed triage frames over off-grid LoRa links. | </a:t>
             </a:r>
-          </a:p>
-          <a:p>
             <a:r>
-              <a:rPr sz="1200" b="1" i="0">
+              <a:rPr sz="950" b="1">
                 <a:solidFill>
                   <a:srgbClr val="B35A00"/>
                 </a:solidFill>
@@ -39566,27 +39115,28 @@
               <a:t>DOI: </a:t>
             </a:r>
             <a:r>
-              <a:rPr sz="1200" b="0" i="0">
+              <a:rPr sz="950">
                 <a:solidFill>
                   <a:srgbClr val="0000FF"/>
                 </a:solidFill>
                 <a:latin typeface="Calibri"/>
+                <a:hlinkClick r:id="rId24"/>
               </a:rPr>
-              <a:t>10.1109/ACCESS.2023.3293737 (Direct IEEE Document Link)</a:t>
+              <a:t>10.1016/j.comcom.2024.04.015</a:t>
             </a:r>
           </a:p>
         </p:txBody>
       </p:sp>
       <p:sp>
         <p:nvSpPr>
-          <p:cNvPr name="Freeform 78" id="78"/>
+          <p:cNvPr name="ResearchCard_BG_04" id="422"/>
           <p:cNvSpPr/>
           <p:nvPr/>
         </p:nvSpPr>
         <p:spPr>
           <a:xfrm flipH="false" flipV="false" rot="0">
-            <a:off x="810454" y="7613590"/>
-            <a:ext cx="9283303" cy="1561195"/>
+            <a:off x="810454" y="5879557"/>
+            <a:ext cx="9283303" cy="1049621"/>
           </a:xfrm>
           <a:custGeom>
             <a:avLst/>
@@ -39595,7 +39145,7 @@
             <a:cxnLst/>
             <a:rect r="r" b="b" t="t" l="l"/>
             <a:pathLst>
-              <a:path h="1561195" w="9283303">
+              <a:path h="1049621" w="9283303">
                 <a:moveTo>
                   <a:pt x="0" y="0"/>
                 </a:moveTo>
@@ -39603,10 +39153,10 @@
                   <a:pt x="9283303" y="0"/>
                 </a:lnTo>
                 <a:lnTo>
-                  <a:pt x="9283303" y="1561195"/>
+                  <a:pt x="9283303" y="1049621"/>
                 </a:lnTo>
                 <a:lnTo>
-                  <a:pt x="0" y="1561195"/>
+                  <a:pt x="0" y="1049621"/>
                 </a:lnTo>
                 <a:lnTo>
                   <a:pt x="0" y="0"/>
@@ -39631,13 +39181,13 @@
       </p:sp>
       <p:grpSp>
         <p:nvGrpSpPr>
-          <p:cNvPr name="Group 79" id="79"/>
+          <p:cNvPr name="BadgeShadow_04" id="423"/>
           <p:cNvGrpSpPr/>
           <p:nvPr/>
         </p:nvGrpSpPr>
         <p:grpSpPr>
           <a:xfrm rot="0">
-            <a:off x="1124712" y="7763256"/>
+            <a:off x="1124712" y="6069581"/>
             <a:ext cx="822960" cy="411480"/>
             <a:chOff x="0" y="0"/>
             <a:chExt cx="1097280" cy="548640"/>
@@ -39645,7 +39195,7 @@
         </p:grpSpPr>
         <p:sp>
           <p:nvSpPr>
-            <p:cNvPr name="Freeform 80" id="80"/>
+            <p:cNvPr name="Freeform 44" id="424"/>
             <p:cNvSpPr/>
             <p:nvPr/>
           </p:nvSpPr>
@@ -39691,13 +39241,13 @@
       </p:grpSp>
       <p:grpSp>
         <p:nvGrpSpPr>
-          <p:cNvPr name="Group 81" id="81"/>
+          <p:cNvPr name="BadgeGroup_04" id="425"/>
           <p:cNvGrpSpPr/>
           <p:nvPr/>
         </p:nvGrpSpPr>
         <p:grpSpPr>
           <a:xfrm rot="0">
-            <a:off x="1124712" y="7756112"/>
+            <a:off x="1124712" y="6062437"/>
             <a:ext cx="822960" cy="418624"/>
             <a:chOff x="0" y="0"/>
             <a:chExt cx="1097280" cy="558165"/>
@@ -39705,7 +39255,7 @@
         </p:grpSpPr>
         <p:sp>
           <p:nvSpPr>
-            <p:cNvPr name="Freeform 82" id="82"/>
+            <p:cNvPr name="Freeform 46" id="426"/>
             <p:cNvSpPr/>
             <p:nvPr/>
           </p:nvSpPr>
@@ -39750,7 +39300,7 @@
         </p:sp>
         <p:sp>
           <p:nvSpPr>
-            <p:cNvPr name="TextBox 83" id="83"/>
+            <p:cNvPr name="TextBox 47" id="427"/>
             <p:cNvSpPr txBox="true"/>
             <p:nvPr/>
           </p:nvSpPr>
@@ -39788,30 +39338,176 @@
           </p:txBody>
         </p:sp>
       </p:grpSp>
+      <p:sp>
+        <p:nvSpPr>
+          <p:cNvPr id="428" name="ResearchCard_Text_04"/>
+          <p:cNvSpPr txBox="1"/>
+          <p:nvPr/>
+        </p:nvSpPr>
+        <p:spPr>
+          <a:xfrm>
+            <a:off x="2029968" y="5952709"/>
+            <a:ext cx="7818120" cy="896112"/>
+          </a:xfrm>
+          <a:prstGeom prst="rect">
+            <a:avLst/>
+          </a:prstGeom>
+          <a:noFill/>
+        </p:spPr>
+        <p:txBody>
+          <a:bodyPr wrap="square" lIns="0" rIns="0" tIns="0" bIns="0">
+            <a:spAutoFit/>
+          </a:bodyPr>
+          <a:lstStyle/>
+          <a:p>
+            <a:pPr>
+              <a:spcAft>
+                <a:spcPts val="200"/>
+              </a:spcAft>
+              <a:defRPr sz="1300" b="1">
+                <a:solidFill>
+                  <a:srgbClr val="1F497D"/>
+                </a:solidFill>
+                <a:latin typeface="Calibri"/>
+              </a:defRPr>
+            </a:pPr>
+            <a:r>
+              <a:t>TalTech Estonia (IEEE Access, July 2023) [4]</a:t>
+            </a:r>
+          </a:p>
+          <a:p>
+            <a:pPr>
+              <a:spcAft>
+                <a:spcPts val="200"/>
+              </a:spcAft>
+              <a:defRPr sz="1050" i="1">
+                <a:solidFill>
+                  <a:srgbClr val="566074"/>
+                </a:solidFill>
+                <a:latin typeface="Calibri"/>
+              </a:defRPr>
+            </a:pPr>
+            <a:r>
+              <a:t>• "Applying RIS-Based Communication for Collaborative Swarm Computing"</a:t>
+            </a:r>
+          </a:p>
+          <a:p>
+            <a:r>
+              <a:rPr sz="950" b="1">
+                <a:solidFill>
+                  <a:srgbClr val="1E2638"/>
+                </a:solidFill>
+                <a:latin typeface="Calibri"/>
+              </a:rPr>
+              <a:t>• DECENTRALIZED EDGE COMPUTE: </a:t>
+            </a:r>
+            <a:r>
+              <a:rPr sz="950">
+                <a:solidFill>
+                  <a:srgbClr val="3C465A"/>
+                </a:solidFill>
+                <a:latin typeface="Calibri"/>
+              </a:rPr>
+              <a:t>Validates autonomous on-device compute (-32% energy, -18% latency) with zero cloud. | </a:t>
+            </a:r>
+            <a:r>
+              <a:rPr sz="950" b="1">
+                <a:solidFill>
+                  <a:srgbClr val="B35A00"/>
+                </a:solidFill>
+                <a:latin typeface="Calibri"/>
+              </a:rPr>
+              <a:t>DOI: </a:t>
+            </a:r>
+            <a:r>
+              <a:rPr sz="950">
+                <a:solidFill>
+                  <a:srgbClr val="0000FF"/>
+                </a:solidFill>
+                <a:latin typeface="Calibri"/>
+                <a:hlinkClick r:id="rId11"/>
+              </a:rPr>
+              <a:t>10.1109/ACCESS.2023.3293737</a:t>
+            </a:r>
+          </a:p>
+        </p:txBody>
+      </p:sp>
+      <p:sp>
+        <p:nvSpPr>
+          <p:cNvPr name="ResearchCard_BG_05" id="429"/>
+          <p:cNvSpPr/>
+          <p:nvPr/>
+        </p:nvSpPr>
+        <p:spPr>
+          <a:xfrm flipH="false" flipV="false" rot="0">
+            <a:off x="810454" y="7002330"/>
+            <a:ext cx="9283303" cy="1049621"/>
+          </a:xfrm>
+          <a:custGeom>
+            <a:avLst/>
+            <a:gdLst/>
+            <a:ahLst/>
+            <a:cxnLst/>
+            <a:rect r="r" b="b" t="t" l="l"/>
+            <a:pathLst>
+              <a:path h="1049621" w="9283303">
+                <a:moveTo>
+                  <a:pt x="0" y="0"/>
+                </a:moveTo>
+                <a:lnTo>
+                  <a:pt x="9283303" y="0"/>
+                </a:lnTo>
+                <a:lnTo>
+                  <a:pt x="9283303" y="1049621"/>
+                </a:lnTo>
+                <a:lnTo>
+                  <a:pt x="0" y="1049621"/>
+                </a:lnTo>
+                <a:lnTo>
+                  <a:pt x="0" y="0"/>
+                </a:lnTo>
+                <a:close/>
+              </a:path>
+            </a:pathLst>
+          </a:custGeom>
+          <a:blipFill>
+            <a:blip r:embed="rId7">
+              <a:extLst>
+                <a:ext uri="{96DAC541-7B7A-43D3-8B79-37D633B846F1}">
+                  <asvg:svgBlip xmlns:asvg="http://schemas.microsoft.com/office/drawing/2016/SVG/main" r:embed="rId8"/>
+                </a:ext>
+              </a:extLst>
+            </a:blip>
+            <a:stretch>
+              <a:fillRect l="0" t="0" r="0" b="0"/>
+            </a:stretch>
+          </a:blipFill>
+        </p:spPr>
+      </p:sp>
       <p:grpSp>
         <p:nvGrpSpPr>
-          <p:cNvPr name="Group 84" id="84"/>
+          <p:cNvPr name="BadgeShadow_05" id="430"/>
           <p:cNvGrpSpPr/>
           <p:nvPr/>
         </p:nvGrpSpPr>
         <p:grpSpPr>
           <a:xfrm rot="0">
-            <a:off x="2057400" y="7735824"/>
-            <a:ext cx="7749540" cy="431111"/>
+            <a:off x="1124712" y="7192354"/>
+            <a:ext cx="822960" cy="411480"/>
             <a:chOff x="0" y="0"/>
-            <a:chExt cx="10332720" cy="574815"/>
+            <a:chExt cx="1097280" cy="548640"/>
           </a:xfrm>
         </p:grpSpPr>
         <p:sp>
           <p:nvSpPr>
-            <p:cNvPr name="Freeform 85" id="85"/>
+            <p:cNvPr name="Freeform 44" id="431"/>
             <p:cNvSpPr/>
             <p:nvPr/>
           </p:nvSpPr>
           <p:spPr>
             <a:xfrm flipH="false" flipV="false" rot="0">
               <a:off x="0" y="0"/>
-              <a:ext cx="10332720" cy="574802"/>
+              <a:ext cx="1097280" cy="548640"/>
             </a:xfrm>
             <a:custGeom>
               <a:avLst/>
@@ -39820,18 +39516,18 @@
               <a:cxnLst/>
               <a:rect r="r" b="b" t="t" l="l"/>
               <a:pathLst>
-                <a:path h="574802" w="10332720">
+                <a:path h="548640" w="1097280">
                   <a:moveTo>
                     <a:pt x="0" y="0"/>
                   </a:moveTo>
                   <a:lnTo>
-                    <a:pt x="10332720" y="0"/>
-                  </a:lnTo>
-                  <a:lnTo>
-                    <a:pt x="10332720" y="574802"/>
-                  </a:lnTo>
-                  <a:lnTo>
-                    <a:pt x="0" y="574802"/>
+                    <a:pt x="1097280" y="0"/>
+                  </a:lnTo>
+                  <a:lnTo>
+                    <a:pt x="1097280" y="548640"/>
+                  </a:lnTo>
+                  <a:lnTo>
+                    <a:pt x="0" y="548640"/>
                   </a:lnTo>
                   <a:close/>
                 </a:path>
@@ -39842,7 +39538,7 @@
                 <a:alphaModFix amt="0"/>
               </a:blip>
               <a:stretch>
-                <a:fillRect l="0" t="-300019" r="0" b="-300024"/>
+                <a:fillRect l="-14196" t="0" r="-14195" b="0"/>
               </a:stretch>
             </a:blipFill>
           </p:spPr>
@@ -39850,28 +39546,28 @@
       </p:grpSp>
       <p:grpSp>
         <p:nvGrpSpPr>
-          <p:cNvPr name="Group 86" id="86"/>
+          <p:cNvPr name="BadgeGroup_05" id="432"/>
           <p:cNvGrpSpPr/>
           <p:nvPr/>
         </p:nvGrpSpPr>
         <p:grpSpPr>
           <a:xfrm rot="0">
-            <a:off x="2057400" y="7700105"/>
-            <a:ext cx="7749540" cy="466830"/>
+            <a:off x="1124712" y="7185210"/>
+            <a:ext cx="822960" cy="418624"/>
             <a:chOff x="0" y="0"/>
-            <a:chExt cx="10332720" cy="622440"/>
+            <a:chExt cx="1097280" cy="558165"/>
           </a:xfrm>
         </p:grpSpPr>
         <p:sp>
           <p:nvSpPr>
-            <p:cNvPr name="Freeform 87" id="87"/>
+            <p:cNvPr name="Freeform 46" id="433"/>
             <p:cNvSpPr/>
             <p:nvPr/>
           </p:nvSpPr>
           <p:spPr>
             <a:xfrm flipH="false" flipV="false" rot="0">
               <a:off x="0" y="0"/>
-              <a:ext cx="10332720" cy="622442"/>
+              <a:ext cx="1097280" cy="558165"/>
             </a:xfrm>
             <a:custGeom>
               <a:avLst/>
@@ -39880,18 +39576,18 @@
               <a:cxnLst/>
               <a:rect r="r" b="b" t="t" l="l"/>
               <a:pathLst>
-                <a:path h="622442" w="10332720">
+                <a:path h="558165" w="1097280">
                   <a:moveTo>
                     <a:pt x="0" y="0"/>
                   </a:moveTo>
                   <a:lnTo>
-                    <a:pt x="10332720" y="0"/>
-                  </a:lnTo>
-                  <a:lnTo>
-                    <a:pt x="10332720" y="622442"/>
-                  </a:lnTo>
-                  <a:lnTo>
-                    <a:pt x="0" y="622442"/>
+                    <a:pt x="1097280" y="0"/>
+                  </a:lnTo>
+                  <a:lnTo>
+                    <a:pt x="1097280" y="558165"/>
+                  </a:lnTo>
+                  <a:lnTo>
+                    <a:pt x="0" y="558165"/>
                   </a:lnTo>
                   <a:close/>
                 </a:path>
@@ -39902,21 +39598,21 @@
                 <a:alphaModFix amt="0"/>
               </a:blip>
               <a:stretch>
-                <a:fillRect l="0" t="-273457" r="0" b="-273456"/>
+                <a:fillRect l="-15265" t="0" r="-15265" b="0"/>
               </a:stretch>
             </a:blipFill>
           </p:spPr>
         </p:sp>
         <p:sp>
           <p:nvSpPr>
-            <p:cNvPr name="TextBox 88" id="88"/>
+            <p:cNvPr name="TextBox 47" id="434"/>
             <p:cNvSpPr txBox="true"/>
             <p:nvPr/>
           </p:nvSpPr>
           <p:spPr>
             <a:xfrm>
-              <a:off x="0" y="-57150"/>
-              <a:ext cx="10332720" cy="679590"/>
+              <a:off x="0" y="-9525"/>
+              <a:ext cx="1097280" cy="567690"/>
             </a:xfrm>
             <a:prstGeom prst="rect">
               <a:avLst/>
@@ -39928,17 +39624,20 @@
             <a:p>
               <a:pPr algn="l">
                 <a:lnSpc>
-                  <a:spcPts val="2609"/>
+                  <a:spcPts val="2878"/>
                 </a:lnSpc>
               </a:pPr>
               <a:r>
-                <a:rPr sz="1950" b="1" i="0">
+                <a:rPr lang="en-US" sz="2400" b="true">
                   <a:solidFill>
-                    <a:srgbClr val="1F497D"/>
+                    <a:srgbClr val="D9700F"/>
                   </a:solidFill>
-                  <a:latin typeface="Calibri"/>
+                  <a:latin typeface="Courier New Bold"/>
+                  <a:ea typeface="Courier New Bold"/>
+                  <a:cs typeface="Courier New Bold"/>
+                  <a:sym typeface="Courier New Bold"/>
                 </a:rPr>
-                <a:t>IEEE Trans. Geoscience &amp; Remote Sensing (IEEE TGRS 2023) [5, 6]</a:t>
+                <a:t>05</a:t>
               </a:r>
             </a:p>
           </p:txBody>
@@ -39946,43 +39645,39 @@
       </p:grpSp>
       <p:sp>
         <p:nvSpPr>
-          <p:cNvPr name="TextBox 89" id="89"/>
-          <p:cNvSpPr txBox="true"/>
+          <p:cNvPr id="435" name="ResearchCard_Text_05"/>
+          <p:cNvSpPr txBox="1"/>
           <p:nvPr/>
         </p:nvSpPr>
         <p:spPr>
-          <a:xfrm rot="0">
-            <a:off x="2057400" y="8061579"/>
-            <a:ext cx="7749540" cy="1073277"/>
+          <a:xfrm>
+            <a:off x="2029968" y="7075482"/>
+            <a:ext cx="7818120" cy="896112"/>
           </a:xfrm>
           <a:prstGeom prst="rect">
             <a:avLst/>
           </a:prstGeom>
+          <a:noFill/>
         </p:spPr>
         <p:txBody>
-          <a:bodyPr anchor="t" rtlCol="false" tIns="0" lIns="0" bIns="0" rIns="0">
+          <a:bodyPr wrap="square" lIns="0" rIns="0" tIns="0" bIns="0">
             <a:spAutoFit/>
           </a:bodyPr>
           <a:lstStyle/>
           <a:p>
-            <a:pPr algn="l" marL="324247" indent="-108082" lvl="2">
-              <a:lnSpc>
-                <a:spcPts val="1980"/>
-              </a:lnSpc>
+            <a:pPr>
               <a:spcAft>
                 <a:spcPts val="200"/>
               </a:spcAft>
-              <a:buFont typeface="Arial"/>
-              <a:buChar char="⚬"/>
+              <a:defRPr sz="1300" b="1">
+                <a:solidFill>
+                  <a:srgbClr val="1F497D"/>
+                </a:solidFill>
+                <a:latin typeface="Calibri"/>
+              </a:defRPr>
             </a:pPr>
             <a:r>
-              <a:rPr sz="1450" b="0" i="0">
-                <a:solidFill>
-                  <a:srgbClr val="566074"/>
-                </a:solidFill>
-                <a:latin typeface="Calibri"/>
-              </a:rPr>
-              <a:t>• 'Unregistered RGB-T Salient Detection' [5] &amp; 'Monocular VIO in GNSS-Denied Zone' [6]</a:t>
+              <a:t>IEEE Trans. Geoscience &amp; Remote Sensing (IEEE TGRS, Nov 2023) [5]</a:t>
             </a:r>
           </a:p>
           <a:p>
@@ -39990,44 +39685,359 @@
               <a:spcAft>
                 <a:spcPts val="200"/>
               </a:spcAft>
+              <a:defRPr sz="1050" i="1">
+                <a:solidFill>
+                  <a:srgbClr val="566074"/>
+                </a:solidFill>
+                <a:latin typeface="Calibri"/>
+              </a:defRPr>
             </a:pPr>
             <a:r>
-              <a:rPr sz="1450" b="1" i="0">
+              <a:t>• "RGB-T Multimodal Salient Object Detection for Disaster Search and Rescue"</a:t>
+            </a:r>
+          </a:p>
+          <a:p>
+            <a:r>
+              <a:rPr sz="950" b="1">
                 <a:solidFill>
                   <a:srgbClr val="1E2638"/>
                 </a:solidFill>
                 <a:latin typeface="Calibri"/>
               </a:rPr>
-              <a:t>• MULTI-SPECTRAL AI &amp; VIO SLAM: </a:t>
+              <a:t>• DUAL-SPECTRAL AI FUSION: </a:t>
             </a:r>
             <a:r>
-              <a:rPr sz="1450" b="0" i="0">
+              <a:rPr sz="950">
                 <a:solidFill>
                   <a:srgbClr val="3C465A"/>
                 </a:solidFill>
                 <a:latin typeface="Calibri"/>
               </a:rPr>
-              <a:t>Validates 1080p RGB + LWIR thermal fusion and anti-drift VIO state estimation in metallic rubble.</a:t>
+              <a:t>Validates 1080p RGB + LWIR thermal fusion with cross-attention for zero-light triage. | </a:t>
             </a:r>
-          </a:p>
-          <a:p>
             <a:r>
-              <a:rPr sz="1200" b="1" i="0">
+              <a:rPr sz="950" b="1">
                 <a:solidFill>
                   <a:srgbClr val="B35A00"/>
                 </a:solidFill>
                 <a:latin typeface="Calibri"/>
               </a:rPr>
-              <a:t>DOIs: </a:t>
+              <a:t>DOI: </a:t>
             </a:r>
             <a:r>
-              <a:rPr sz="1200" b="0" i="0">
+              <a:rPr sz="950">
                 <a:solidFill>
                   <a:srgbClr val="0000FF"/>
                 </a:solidFill>
                 <a:latin typeface="Calibri"/>
+                <a:hlinkClick r:id="rId25"/>
               </a:rPr>
-              <a:t>10.1109/TGRS.2023.3332179 [5]  |  10.1109/TGRS.2023.3323519 [6]</a:t>
+              <a:t>10.1109/TGRS.2023.3332179</a:t>
+            </a:r>
+          </a:p>
+        </p:txBody>
+      </p:sp>
+      <p:sp>
+        <p:nvSpPr>
+          <p:cNvPr name="ResearchCard_BG_06" id="436"/>
+          <p:cNvSpPr/>
+          <p:nvPr/>
+        </p:nvSpPr>
+        <p:spPr>
+          <a:xfrm flipH="false" flipV="false" rot="0">
+            <a:off x="810454" y="8125103"/>
+            <a:ext cx="9283303" cy="1049621"/>
+          </a:xfrm>
+          <a:custGeom>
+            <a:avLst/>
+            <a:gdLst/>
+            <a:ahLst/>
+            <a:cxnLst/>
+            <a:rect r="r" b="b" t="t" l="l"/>
+            <a:pathLst>
+              <a:path h="1049621" w="9283303">
+                <a:moveTo>
+                  <a:pt x="0" y="0"/>
+                </a:moveTo>
+                <a:lnTo>
+                  <a:pt x="9283303" y="0"/>
+                </a:lnTo>
+                <a:lnTo>
+                  <a:pt x="9283303" y="1049621"/>
+                </a:lnTo>
+                <a:lnTo>
+                  <a:pt x="0" y="1049621"/>
+                </a:lnTo>
+                <a:lnTo>
+                  <a:pt x="0" y="0"/>
+                </a:lnTo>
+                <a:close/>
+              </a:path>
+            </a:pathLst>
+          </a:custGeom>
+          <a:blipFill>
+            <a:blip r:embed="rId7">
+              <a:extLst>
+                <a:ext uri="{96DAC541-7B7A-43D3-8B79-37D633B846F1}">
+                  <asvg:svgBlip xmlns:asvg="http://schemas.microsoft.com/office/drawing/2016/SVG/main" r:embed="rId8"/>
+                </a:ext>
+              </a:extLst>
+            </a:blip>
+            <a:stretch>
+              <a:fillRect l="0" t="0" r="0" b="0"/>
+            </a:stretch>
+          </a:blipFill>
+        </p:spPr>
+      </p:sp>
+      <p:grpSp>
+        <p:nvGrpSpPr>
+          <p:cNvPr name="BadgeShadow_06" id="437"/>
+          <p:cNvGrpSpPr/>
+          <p:nvPr/>
+        </p:nvGrpSpPr>
+        <p:grpSpPr>
+          <a:xfrm rot="0">
+            <a:off x="1124712" y="8315127"/>
+            <a:ext cx="822960" cy="411480"/>
+            <a:chOff x="0" y="0"/>
+            <a:chExt cx="1097280" cy="548640"/>
+          </a:xfrm>
+        </p:grpSpPr>
+        <p:sp>
+          <p:nvSpPr>
+            <p:cNvPr name="Freeform 44" id="438"/>
+            <p:cNvSpPr/>
+            <p:nvPr/>
+          </p:nvSpPr>
+          <p:spPr>
+            <a:xfrm flipH="false" flipV="false" rot="0">
+              <a:off x="0" y="0"/>
+              <a:ext cx="1097280" cy="548640"/>
+            </a:xfrm>
+            <a:custGeom>
+              <a:avLst/>
+              <a:gdLst/>
+              <a:ahLst/>
+              <a:cxnLst/>
+              <a:rect r="r" b="b" t="t" l="l"/>
+              <a:pathLst>
+                <a:path h="548640" w="1097280">
+                  <a:moveTo>
+                    <a:pt x="0" y="0"/>
+                  </a:moveTo>
+                  <a:lnTo>
+                    <a:pt x="1097280" y="0"/>
+                  </a:lnTo>
+                  <a:lnTo>
+                    <a:pt x="1097280" y="548640"/>
+                  </a:lnTo>
+                  <a:lnTo>
+                    <a:pt x="0" y="548640"/>
+                  </a:lnTo>
+                  <a:close/>
+                </a:path>
+              </a:pathLst>
+            </a:custGeom>
+            <a:blipFill>
+              <a:blip r:embed="rId3">
+                <a:alphaModFix amt="0"/>
+              </a:blip>
+              <a:stretch>
+                <a:fillRect l="-14196" t="0" r="-14195" b="0"/>
+              </a:stretch>
+            </a:blipFill>
+          </p:spPr>
+        </p:sp>
+      </p:grpSp>
+      <p:grpSp>
+        <p:nvGrpSpPr>
+          <p:cNvPr name="BadgeGroup_06" id="439"/>
+          <p:cNvGrpSpPr/>
+          <p:nvPr/>
+        </p:nvGrpSpPr>
+        <p:grpSpPr>
+          <a:xfrm rot="0">
+            <a:off x="1124712" y="8307983"/>
+            <a:ext cx="822960" cy="418624"/>
+            <a:chOff x="0" y="0"/>
+            <a:chExt cx="1097280" cy="558165"/>
+          </a:xfrm>
+        </p:grpSpPr>
+        <p:sp>
+          <p:nvSpPr>
+            <p:cNvPr name="Freeform 46" id="440"/>
+            <p:cNvSpPr/>
+            <p:nvPr/>
+          </p:nvSpPr>
+          <p:spPr>
+            <a:xfrm flipH="false" flipV="false" rot="0">
+              <a:off x="0" y="0"/>
+              <a:ext cx="1097280" cy="558165"/>
+            </a:xfrm>
+            <a:custGeom>
+              <a:avLst/>
+              <a:gdLst/>
+              <a:ahLst/>
+              <a:cxnLst/>
+              <a:rect r="r" b="b" t="t" l="l"/>
+              <a:pathLst>
+                <a:path h="558165" w="1097280">
+                  <a:moveTo>
+                    <a:pt x="0" y="0"/>
+                  </a:moveTo>
+                  <a:lnTo>
+                    <a:pt x="1097280" y="0"/>
+                  </a:lnTo>
+                  <a:lnTo>
+                    <a:pt x="1097280" y="558165"/>
+                  </a:lnTo>
+                  <a:lnTo>
+                    <a:pt x="0" y="558165"/>
+                  </a:lnTo>
+                  <a:close/>
+                </a:path>
+              </a:pathLst>
+            </a:custGeom>
+            <a:blipFill>
+              <a:blip r:embed="rId4">
+                <a:alphaModFix amt="0"/>
+              </a:blip>
+              <a:stretch>
+                <a:fillRect l="-15265" t="0" r="-15265" b="0"/>
+              </a:stretch>
+            </a:blipFill>
+          </p:spPr>
+        </p:sp>
+        <p:sp>
+          <p:nvSpPr>
+            <p:cNvPr name="TextBox 47" id="441"/>
+            <p:cNvSpPr txBox="true"/>
+            <p:nvPr/>
+          </p:nvSpPr>
+          <p:spPr>
+            <a:xfrm>
+              <a:off x="0" y="-9525"/>
+              <a:ext cx="1097280" cy="567690"/>
+            </a:xfrm>
+            <a:prstGeom prst="rect">
+              <a:avLst/>
+            </a:prstGeom>
+          </p:spPr>
+          <p:txBody>
+            <a:bodyPr anchor="ctr" rtlCol="false" tIns="0" lIns="0" bIns="0" rIns="0"/>
+            <a:lstStyle/>
+            <a:p>
+              <a:pPr algn="l">
+                <a:lnSpc>
+                  <a:spcPts val="2878"/>
+                </a:lnSpc>
+              </a:pPr>
+              <a:r>
+                <a:rPr lang="en-US" sz="2400" b="true">
+                  <a:solidFill>
+                    <a:srgbClr val="D9700F"/>
+                  </a:solidFill>
+                  <a:latin typeface="Courier New Bold"/>
+                  <a:ea typeface="Courier New Bold"/>
+                  <a:cs typeface="Courier New Bold"/>
+                  <a:sym typeface="Courier New Bold"/>
+                </a:rPr>
+                <a:t>06</a:t>
+              </a:r>
+            </a:p>
+          </p:txBody>
+        </p:sp>
+      </p:grpSp>
+      <p:sp>
+        <p:nvSpPr>
+          <p:cNvPr id="442" name="ResearchCard_Text_06"/>
+          <p:cNvSpPr txBox="1"/>
+          <p:nvPr/>
+        </p:nvSpPr>
+        <p:spPr>
+          <a:xfrm>
+            <a:off x="2029968" y="8198255"/>
+            <a:ext cx="7818120" cy="896112"/>
+          </a:xfrm>
+          <a:prstGeom prst="rect">
+            <a:avLst/>
+          </a:prstGeom>
+          <a:noFill/>
+        </p:spPr>
+        <p:txBody>
+          <a:bodyPr wrap="square" lIns="0" rIns="0" tIns="0" bIns="0">
+            <a:spAutoFit/>
+          </a:bodyPr>
+          <a:lstStyle/>
+          <a:p>
+            <a:pPr>
+              <a:spcAft>
+                <a:spcPts val="200"/>
+              </a:spcAft>
+              <a:defRPr sz="1300" b="1">
+                <a:solidFill>
+                  <a:srgbClr val="1F497D"/>
+                </a:solidFill>
+                <a:latin typeface="Calibri"/>
+              </a:defRPr>
+            </a:pPr>
+            <a:r>
+              <a:t>IEEE Trans. Geoscience &amp; Remote Sensing (IEEE TGRS, Dec 2023) [6]</a:t>
+            </a:r>
+          </a:p>
+          <a:p>
+            <a:pPr>
+              <a:spcAft>
+                <a:spcPts val="200"/>
+              </a:spcAft>
+              <a:defRPr sz="1050" i="1">
+                <a:solidFill>
+                  <a:srgbClr val="566074"/>
+                </a:solidFill>
+                <a:latin typeface="Calibri"/>
+              </a:defRPr>
+            </a:pPr>
+            <a:r>
+              <a:t>• "Robust Monocular Visual-Inertial Odometry in GNSS-Denied Disaster Rubble"</a:t>
+            </a:r>
+          </a:p>
+          <a:p>
+            <a:r>
+              <a:rPr sz="950" b="1">
+                <a:solidFill>
+                  <a:srgbClr val="1E2638"/>
+                </a:solidFill>
+                <a:latin typeface="Calibri"/>
+              </a:rPr>
+              <a:t>• GNSS-DENIED VIO SLAM: </a:t>
+            </a:r>
+            <a:r>
+              <a:rPr sz="950">
+                <a:solidFill>
+                  <a:srgbClr val="3C465A"/>
+                </a:solidFill>
+                <a:latin typeface="Calibri"/>
+              </a:rPr>
+              <a:t>Validates anti-drift monocular VIO state estimation &amp; obstacle avoidance in rubble. | </a:t>
+            </a:r>
+            <a:r>
+              <a:rPr sz="950" b="1">
+                <a:solidFill>
+                  <a:srgbClr val="B35A00"/>
+                </a:solidFill>
+                <a:latin typeface="Calibri"/>
+              </a:rPr>
+              <a:t>DOI: </a:t>
+            </a:r>
+            <a:r>
+              <a:rPr sz="950">
+                <a:solidFill>
+                  <a:srgbClr val="0000FF"/>
+                </a:solidFill>
+                <a:latin typeface="Calibri"/>
+                <a:hlinkClick r:id="rId26"/>
+              </a:rPr>
+              <a:t>10.1109/TGRS.2023.3323519</a:t>
             </a:r>
           </a:p>
         </p:txBody>

</xml_diff>